<commit_message>
Tone down scenario 1 slide colors
</commit_message>
<xml_diff>
--- a/presentation/scenario_1_better_deadline_scheduling.pptx
+++ b/presentation/scenario_1_better_deadline_scheduling.pptx
@@ -2,13 +2,13 @@
 <file path=ppt/presentation.xml><?xml version="1.0" encoding="utf-8"?>
 <p:presentation xmlns:p="http://schemas.openxmlformats.org/presentationml/2006/main">
   <p:sldMasterIdLst>
-    <p:sldMasterId xmlns:r="http://schemas.openxmlformats.org/officeDocument/2006/relationships" id="2147483648" r:id="R0f96691572284e58"/>
+    <p:sldMasterId xmlns:r="http://schemas.openxmlformats.org/officeDocument/2006/relationships" id="2147483648" r:id="Rba83695a4ee44ac2"/>
   </p:sldMasterIdLst>
   <p:notesMasterIdLst>
-    <p:notesMasterId xmlns:r="http://schemas.openxmlformats.org/officeDocument/2006/relationships" r:id="R0c3f0c9653134df8"/>
+    <p:notesMasterId xmlns:r="http://schemas.openxmlformats.org/officeDocument/2006/relationships" r:id="R2527f596c2bc4f93"/>
   </p:notesMasterIdLst>
   <p:sldIdLst>
-    <p:sldId xmlns:r="http://schemas.openxmlformats.org/officeDocument/2006/relationships" id="256" r:id="R22518166623c4860"/>
+    <p:sldId xmlns:r="http://schemas.openxmlformats.org/officeDocument/2006/relationships" id="256" r:id="Rc897cdaada4e4ef8"/>
   </p:sldIdLst>
   <p:sldSz cx="12192000" cy="6858000"/>
   <p:notesSz cx="6858000" cy="9144000"/>
@@ -555,7 +555,7 @@
   </p:cSld>
   <p:clrMap bg1="lt1" tx1="dk1" bg2="lt2" tx2="dk2" accent1="accent1" accent2="accent2" accent3="accent3" accent4="accent4" accent5="accent5" accent6="accent6" hlink="hlink" folHlink="folHlink"/>
   <p:sldLayoutIdLst>
-    <p:sldLayoutId xmlns:r="http://schemas.openxmlformats.org/officeDocument/2006/relationships" id="2147483649" r:id="R9c1597b7e9814ca6"/>
+    <p:sldLayoutId xmlns:r="http://schemas.openxmlformats.org/officeDocument/2006/relationships" id="2147483649" r:id="R74a13480733a4493"/>
   </p:sldLayoutIdLst>
   <p:txStyles>
     <p:titleStyle>
@@ -1106,7 +1106,7 @@
           <p:cNvPr id="47" name="">
             <a:extLst xmlns:a="http://schemas.openxmlformats.org/drawingml/2006/main">
               <a:ext uri="{FF2B5EF4-FFF2-40B4-BE49-F238E27FC236}">
-                <a16:creationId xmlns:a16="http://schemas.microsoft.com/office/drawing/2014/main" id="{96F83BF4-468D-40E5-8611-224AD1DC70D7}"/>
+                <a16:creationId xmlns:a16="http://schemas.microsoft.com/office/drawing/2014/main" id="{3BC98D19-F53D-4FF9-8096-28EC7893A51E}"/>
               </a:ext>
             </a:extLst>
           </p:cNvPr>
@@ -1164,7 +1164,7 @@
           <p:cNvPr id="2" name="">
             <a:extLst xmlns:a="http://schemas.openxmlformats.org/drawingml/2006/main">
               <a:ext uri="{FF2B5EF4-FFF2-40B4-BE49-F238E27FC236}">
-                <a16:creationId xmlns:a16="http://schemas.microsoft.com/office/drawing/2014/main" id="{378967E1-04C6-49C3-B8A1-0AAC148C2C0D}"/>
+                <a16:creationId xmlns:a16="http://schemas.microsoft.com/office/drawing/2014/main" id="{33293D1C-A02C-4180-849A-C87FF6775DA8}"/>
               </a:ext>
             </a:extLst>
           </p:cNvPr>
@@ -1222,7 +1222,7 @@
           <p:cNvPr id="3" name="">
             <a:extLst xmlns:a="http://schemas.openxmlformats.org/drawingml/2006/main">
               <a:ext uri="{FF2B5EF4-FFF2-40B4-BE49-F238E27FC236}">
-                <a16:creationId xmlns:a16="http://schemas.microsoft.com/office/drawing/2014/main" id="{1425EF19-9164-4252-AE56-76896872C41D}"/>
+                <a16:creationId xmlns:a16="http://schemas.microsoft.com/office/drawing/2014/main" id="{980AE924-EF0E-4825-B250-42B88BA3B71E}"/>
               </a:ext>
             </a:extLst>
           </p:cNvPr>
@@ -1254,7 +1254,7 @@
             <a:pPr algn="r">
               <a:defRPr sz="1350" b="1">
                 <a:solidFill>
-                  <a:srgbClr val="059669"/>
+                  <a:srgbClr val="2F6F56"/>
                 </a:solidFill>
                 <a:latin typeface="Helvetica Neue"/>
                 <a:ea typeface="Helvetica Neue"/>
@@ -1264,7 +1264,7 @@
             <a:r>
               <a:rPr sz="1350" b="1">
                 <a:solidFill>
-                  <a:srgbClr val="059669"/>
+                  <a:srgbClr val="2F6F56"/>
                 </a:solidFill>
                 <a:latin typeface="Helvetica Neue"/>
                 <a:ea typeface="Helvetica Neue"/>
@@ -1280,7 +1280,7 @@
           <p:cNvPr id="4" name="">
             <a:extLst xmlns:a="http://schemas.openxmlformats.org/drawingml/2006/main">
               <a:ext uri="{FF2B5EF4-FFF2-40B4-BE49-F238E27FC236}">
-                <a16:creationId xmlns:a16="http://schemas.microsoft.com/office/drawing/2014/main" id="{90FB63C5-2DE1-4A97-912A-99D7C03BC779}"/>
+                <a16:creationId xmlns:a16="http://schemas.microsoft.com/office/drawing/2014/main" id="{6EE27B54-0CD6-4221-AEA6-F93AF7F754F5}"/>
               </a:ext>
             </a:extLst>
           </p:cNvPr>
@@ -1311,7 +1311,7 @@
           <p:cNvPr id="5" name="">
             <a:extLst xmlns:a="http://schemas.openxmlformats.org/drawingml/2006/main">
               <a:ext uri="{FF2B5EF4-FFF2-40B4-BE49-F238E27FC236}">
-                <a16:creationId xmlns:a16="http://schemas.microsoft.com/office/drawing/2014/main" id="{0D0B63B5-D2C3-47BE-A9A9-6D2A62646F32}"/>
+                <a16:creationId xmlns:a16="http://schemas.microsoft.com/office/drawing/2014/main" id="{E187358B-7E66-46E7-A5E4-D8E5FFDD341D}"/>
               </a:ext>
             </a:extLst>
           </p:cNvPr>
@@ -1369,7 +1369,7 @@
           <p:cNvPr id="6" name="">
             <a:extLst xmlns:a="http://schemas.openxmlformats.org/drawingml/2006/main">
               <a:ext uri="{FF2B5EF4-FFF2-40B4-BE49-F238E27FC236}">
-                <a16:creationId xmlns:a16="http://schemas.microsoft.com/office/drawing/2014/main" id="{526041A5-3A7B-418D-B985-8B9A4BB8CB41}"/>
+                <a16:creationId xmlns:a16="http://schemas.microsoft.com/office/drawing/2014/main" id="{D14FAC1A-EF9B-4F59-8D42-730AA1EC08FE}"/>
               </a:ext>
             </a:extLst>
           </p:cNvPr>
@@ -1409,7 +1409,7 @@
           <p:cNvPr id="7" name="">
             <a:extLst xmlns:a="http://schemas.openxmlformats.org/drawingml/2006/main">
               <a:ext uri="{FF2B5EF4-FFF2-40B4-BE49-F238E27FC236}">
-                <a16:creationId xmlns:a16="http://schemas.microsoft.com/office/drawing/2014/main" id="{4EA32C0A-8F1B-45F6-B2E3-51F69AC1789F}"/>
+                <a16:creationId xmlns:a16="http://schemas.microsoft.com/office/drawing/2014/main" id="{F5C50361-84EE-4FA5-85FE-BA0C0169C46D}"/>
               </a:ext>
             </a:extLst>
           </p:cNvPr>
@@ -1427,11 +1427,11 @@
             <a:avLst/>
           </a:prstGeom>
           <a:solidFill xmlns:a="http://schemas.openxmlformats.org/drawingml/2006/main">
-            <a:srgbClr val="2563EB"/>
+            <a:srgbClr val="1F4E79"/>
           </a:solidFill>
           <a:ln xmlns:a="http://schemas.openxmlformats.org/drawingml/2006/main" w="0">
             <a:solidFill>
-              <a:srgbClr val="2563EB"/>
+              <a:srgbClr val="1F4E79"/>
             </a:solidFill>
             <a:prstDash val="solid"/>
           </a:ln>
@@ -1442,7 +1442,7 @@
           <p:cNvPr id="8" name="">
             <a:extLst xmlns:a="http://schemas.openxmlformats.org/drawingml/2006/main">
               <a:ext uri="{FF2B5EF4-FFF2-40B4-BE49-F238E27FC236}">
-                <a16:creationId xmlns:a16="http://schemas.microsoft.com/office/drawing/2014/main" id="{6550BC6F-E1D1-48FB-9CDF-65D2183921B8}"/>
+                <a16:creationId xmlns:a16="http://schemas.microsoft.com/office/drawing/2014/main" id="{381C076F-DAF8-4A9C-9C5A-7CB75FDD53F1}"/>
               </a:ext>
             </a:extLst>
           </p:cNvPr>
@@ -1500,7 +1500,7 @@
           <p:cNvPr id="9" name="">
             <a:extLst xmlns:a="http://schemas.openxmlformats.org/drawingml/2006/main">
               <a:ext uri="{FF2B5EF4-FFF2-40B4-BE49-F238E27FC236}">
-                <a16:creationId xmlns:a16="http://schemas.microsoft.com/office/drawing/2014/main" id="{97DF29DD-B606-4393-889E-17203EDA9D67}"/>
+                <a16:creationId xmlns:a16="http://schemas.microsoft.com/office/drawing/2014/main" id="{D2E079A9-983B-431C-8AA8-972C8F3A0620}"/>
               </a:ext>
             </a:extLst>
           </p:cNvPr>
@@ -1540,7 +1540,7 @@
           <p:cNvPr id="10" name="">
             <a:extLst xmlns:a="http://schemas.openxmlformats.org/drawingml/2006/main">
               <a:ext uri="{FF2B5EF4-FFF2-40B4-BE49-F238E27FC236}">
-                <a16:creationId xmlns:a16="http://schemas.microsoft.com/office/drawing/2014/main" id="{95A6BABB-5620-4DEC-A78D-4CB9F9D63DAE}"/>
+                <a16:creationId xmlns:a16="http://schemas.microsoft.com/office/drawing/2014/main" id="{2B84841C-6321-486A-9B29-908128B7D7C9}"/>
               </a:ext>
             </a:extLst>
           </p:cNvPr>
@@ -1558,11 +1558,11 @@
             <a:avLst/>
           </a:prstGeom>
           <a:solidFill xmlns:a="http://schemas.openxmlformats.org/drawingml/2006/main">
-            <a:srgbClr val="2563EB"/>
+            <a:srgbClr val="1F4E79"/>
           </a:solidFill>
           <a:ln xmlns:a="http://schemas.openxmlformats.org/drawingml/2006/main" w="0">
             <a:solidFill>
-              <a:srgbClr val="2563EB"/>
+              <a:srgbClr val="1F4E79"/>
             </a:solidFill>
             <a:prstDash val="solid"/>
           </a:ln>
@@ -1573,7 +1573,7 @@
           <p:cNvPr id="11" name="">
             <a:extLst xmlns:a="http://schemas.openxmlformats.org/drawingml/2006/main">
               <a:ext uri="{FF2B5EF4-FFF2-40B4-BE49-F238E27FC236}">
-                <a16:creationId xmlns:a16="http://schemas.microsoft.com/office/drawing/2014/main" id="{F2F3443E-53BF-41FE-9DB8-1ACED73FB83F}"/>
+                <a16:creationId xmlns:a16="http://schemas.microsoft.com/office/drawing/2014/main" id="{457F0449-4B20-4DB3-8185-52D336ACCBFD}"/>
               </a:ext>
             </a:extLst>
           </p:cNvPr>
@@ -1631,7 +1631,7 @@
           <p:cNvPr id="12" name="">
             <a:extLst xmlns:a="http://schemas.openxmlformats.org/drawingml/2006/main">
               <a:ext uri="{FF2B5EF4-FFF2-40B4-BE49-F238E27FC236}">
-                <a16:creationId xmlns:a16="http://schemas.microsoft.com/office/drawing/2014/main" id="{3E71A874-7393-4059-B6F1-13754775E185}"/>
+                <a16:creationId xmlns:a16="http://schemas.microsoft.com/office/drawing/2014/main" id="{1A7DF230-69C3-42C5-9FDD-FAA032E3CE07}"/>
               </a:ext>
             </a:extLst>
           </p:cNvPr>
@@ -1671,7 +1671,7 @@
           <p:cNvPr id="13" name="">
             <a:extLst xmlns:a="http://schemas.openxmlformats.org/drawingml/2006/main">
               <a:ext uri="{FF2B5EF4-FFF2-40B4-BE49-F238E27FC236}">
-                <a16:creationId xmlns:a16="http://schemas.microsoft.com/office/drawing/2014/main" id="{A0E53D71-9F85-4925-83C1-985F05BE6473}"/>
+                <a16:creationId xmlns:a16="http://schemas.microsoft.com/office/drawing/2014/main" id="{F5B54E69-5EF6-4DB7-8445-6D7068F69663}"/>
               </a:ext>
             </a:extLst>
           </p:cNvPr>
@@ -1689,11 +1689,11 @@
             <a:avLst/>
           </a:prstGeom>
           <a:solidFill xmlns:a="http://schemas.openxmlformats.org/drawingml/2006/main">
-            <a:srgbClr val="2563EB"/>
+            <a:srgbClr val="1F4E79"/>
           </a:solidFill>
           <a:ln xmlns:a="http://schemas.openxmlformats.org/drawingml/2006/main" w="0">
             <a:solidFill>
-              <a:srgbClr val="2563EB"/>
+              <a:srgbClr val="1F4E79"/>
             </a:solidFill>
             <a:prstDash val="solid"/>
           </a:ln>
@@ -1704,7 +1704,7 @@
           <p:cNvPr id="14" name="">
             <a:extLst xmlns:a="http://schemas.openxmlformats.org/drawingml/2006/main">
               <a:ext uri="{FF2B5EF4-FFF2-40B4-BE49-F238E27FC236}">
-                <a16:creationId xmlns:a16="http://schemas.microsoft.com/office/drawing/2014/main" id="{B1EE76BA-682D-46A1-823D-BBF2181F44AB}"/>
+                <a16:creationId xmlns:a16="http://schemas.microsoft.com/office/drawing/2014/main" id="{128DD02C-4570-4E10-A5EB-EA8F37710D42}"/>
               </a:ext>
             </a:extLst>
           </p:cNvPr>
@@ -1762,7 +1762,7 @@
           <p:cNvPr id="15" name="">
             <a:extLst xmlns:a="http://schemas.openxmlformats.org/drawingml/2006/main">
               <a:ext uri="{FF2B5EF4-FFF2-40B4-BE49-F238E27FC236}">
-                <a16:creationId xmlns:a16="http://schemas.microsoft.com/office/drawing/2014/main" id="{865ABD22-D54E-4454-B691-3FBF36D19079}"/>
+                <a16:creationId xmlns:a16="http://schemas.microsoft.com/office/drawing/2014/main" id="{E0F085D4-A666-41AD-B45A-5254E67D3DB7}"/>
               </a:ext>
             </a:extLst>
           </p:cNvPr>
@@ -1802,7 +1802,7 @@
           <p:cNvPr id="16" name="">
             <a:extLst xmlns:a="http://schemas.openxmlformats.org/drawingml/2006/main">
               <a:ext uri="{FF2B5EF4-FFF2-40B4-BE49-F238E27FC236}">
-                <a16:creationId xmlns:a16="http://schemas.microsoft.com/office/drawing/2014/main" id="{EE33F73B-61C0-46BB-A04F-2F5EE996ADA3}"/>
+                <a16:creationId xmlns:a16="http://schemas.microsoft.com/office/drawing/2014/main" id="{BE3C5693-D32A-4ACD-9BF7-DB82563C3C4D}"/>
               </a:ext>
             </a:extLst>
           </p:cNvPr>
@@ -1820,11 +1820,11 @@
             <a:avLst/>
           </a:prstGeom>
           <a:solidFill xmlns:a="http://schemas.openxmlformats.org/drawingml/2006/main">
-            <a:srgbClr val="2563EB"/>
+            <a:srgbClr val="1F4E79"/>
           </a:solidFill>
           <a:ln xmlns:a="http://schemas.openxmlformats.org/drawingml/2006/main" w="0">
             <a:solidFill>
-              <a:srgbClr val="2563EB"/>
+              <a:srgbClr val="1F4E79"/>
             </a:solidFill>
             <a:prstDash val="solid"/>
           </a:ln>
@@ -1835,7 +1835,7 @@
           <p:cNvPr id="17" name="">
             <a:extLst xmlns:a="http://schemas.openxmlformats.org/drawingml/2006/main">
               <a:ext uri="{FF2B5EF4-FFF2-40B4-BE49-F238E27FC236}">
-                <a16:creationId xmlns:a16="http://schemas.microsoft.com/office/drawing/2014/main" id="{CA70C8BF-55D3-4354-ACEF-0B3BBC367EA3}"/>
+                <a16:creationId xmlns:a16="http://schemas.microsoft.com/office/drawing/2014/main" id="{BEA6E994-A423-4BDA-B1C5-CCC50232FEE5}"/>
               </a:ext>
             </a:extLst>
           </p:cNvPr>
@@ -1893,7 +1893,7 @@
           <p:cNvPr id="18" name="">
             <a:extLst xmlns:a="http://schemas.openxmlformats.org/drawingml/2006/main">
               <a:ext uri="{FF2B5EF4-FFF2-40B4-BE49-F238E27FC236}">
-                <a16:creationId xmlns:a16="http://schemas.microsoft.com/office/drawing/2014/main" id="{5A171811-0741-4E71-A89B-1FA5A6456155}"/>
+                <a16:creationId xmlns:a16="http://schemas.microsoft.com/office/drawing/2014/main" id="{AC501E61-E296-4F95-AB2D-2A2DA9B89E72}"/>
               </a:ext>
             </a:extLst>
           </p:cNvPr>
@@ -1926,7 +1926,7 @@
           <p:cNvPr id="19" name="">
             <a:extLst xmlns:a="http://schemas.openxmlformats.org/drawingml/2006/main">
               <a:ext uri="{FF2B5EF4-FFF2-40B4-BE49-F238E27FC236}">
-                <a16:creationId xmlns:a16="http://schemas.microsoft.com/office/drawing/2014/main" id="{EB846C7E-48CF-400F-87EB-38B0C8B46E0D}"/>
+                <a16:creationId xmlns:a16="http://schemas.microsoft.com/office/drawing/2014/main" id="{07C2014C-FB4A-4FFA-B725-45B83FDFD37F}"/>
               </a:ext>
             </a:extLst>
           </p:cNvPr>
@@ -1984,7 +1984,7 @@
           <p:cNvPr id="20" name="">
             <a:extLst xmlns:a="http://schemas.openxmlformats.org/drawingml/2006/main">
               <a:ext uri="{FF2B5EF4-FFF2-40B4-BE49-F238E27FC236}">
-                <a16:creationId xmlns:a16="http://schemas.microsoft.com/office/drawing/2014/main" id="{DF333472-37DF-4058-93A1-F6FF1D10936D}"/>
+                <a16:creationId xmlns:a16="http://schemas.microsoft.com/office/drawing/2014/main" id="{BBF48F68-6559-4E96-8E5C-5C3C7F28CF17}"/>
               </a:ext>
             </a:extLst>
           </p:cNvPr>
@@ -2042,7 +2042,7 @@
           <p:cNvPr id="21" name="">
             <a:extLst xmlns:a="http://schemas.openxmlformats.org/drawingml/2006/main">
               <a:ext uri="{FF2B5EF4-FFF2-40B4-BE49-F238E27FC236}">
-                <a16:creationId xmlns:a16="http://schemas.microsoft.com/office/drawing/2014/main" id="{89C25424-BDC4-4EDD-8F9B-98C20CD88DCF}"/>
+                <a16:creationId xmlns:a16="http://schemas.microsoft.com/office/drawing/2014/main" id="{E8B29F46-BC99-4D2D-BED5-4A58A5BDE7FC}"/>
               </a:ext>
             </a:extLst>
           </p:cNvPr>
@@ -2100,7 +2100,7 @@
           <p:cNvPr id="22" name="">
             <a:extLst xmlns:a="http://schemas.openxmlformats.org/drawingml/2006/main">
               <a:ext uri="{FF2B5EF4-FFF2-40B4-BE49-F238E27FC236}">
-                <a16:creationId xmlns:a16="http://schemas.microsoft.com/office/drawing/2014/main" id="{EF4E6DDB-1A2B-4BCB-AAFE-092D5DB8B1B2}"/>
+                <a16:creationId xmlns:a16="http://schemas.microsoft.com/office/drawing/2014/main" id="{35110F0B-39E0-4FFA-8258-C7A161D8ECAC}"/>
               </a:ext>
             </a:extLst>
           </p:cNvPr>
@@ -2158,7 +2158,7 @@
           <p:cNvPr id="23" name="">
             <a:extLst xmlns:a="http://schemas.openxmlformats.org/drawingml/2006/main">
               <a:ext uri="{FF2B5EF4-FFF2-40B4-BE49-F238E27FC236}">
-                <a16:creationId xmlns:a16="http://schemas.microsoft.com/office/drawing/2014/main" id="{11D18C9B-C709-4D8D-AC2E-820225034A04}"/>
+                <a16:creationId xmlns:a16="http://schemas.microsoft.com/office/drawing/2014/main" id="{DA1D0572-D019-45CF-9A30-A8B843AEEB82}"/>
               </a:ext>
             </a:extLst>
           </p:cNvPr>
@@ -2176,7 +2176,7 @@
             <a:avLst/>
           </a:prstGeom>
           <a:solidFill xmlns:a="http://schemas.openxmlformats.org/drawingml/2006/main">
-            <a:srgbClr val="EFF6FF"/>
+            <a:srgbClr val="F8FAFC"/>
           </a:solidFill>
           <a:ln xmlns:a="http://schemas.openxmlformats.org/drawingml/2006/main" w="9525">
             <a:solidFill>
@@ -2191,7 +2191,7 @@
           <p:cNvPr id="24" name="">
             <a:extLst xmlns:a="http://schemas.openxmlformats.org/drawingml/2006/main">
               <a:ext uri="{FF2B5EF4-FFF2-40B4-BE49-F238E27FC236}">
-                <a16:creationId xmlns:a16="http://schemas.microsoft.com/office/drawing/2014/main" id="{DF1B474D-2204-4738-A5CA-BB8C538B17EF}"/>
+                <a16:creationId xmlns:a16="http://schemas.microsoft.com/office/drawing/2014/main" id="{8E4FA3B9-B6C6-4DCB-97EF-4F92787A021C}"/>
               </a:ext>
             </a:extLst>
           </p:cNvPr>
@@ -2249,7 +2249,7 @@
           <p:cNvPr id="25" name="">
             <a:extLst xmlns:a="http://schemas.openxmlformats.org/drawingml/2006/main">
               <a:ext uri="{FF2B5EF4-FFF2-40B4-BE49-F238E27FC236}">
-                <a16:creationId xmlns:a16="http://schemas.microsoft.com/office/drawing/2014/main" id="{12C41375-99CE-441F-A317-87BD92D2451F}"/>
+                <a16:creationId xmlns:a16="http://schemas.microsoft.com/office/drawing/2014/main" id="{B69AD552-F8DE-49EF-BF48-C117DBD75C1C}"/>
               </a:ext>
             </a:extLst>
           </p:cNvPr>
@@ -2281,7 +2281,7 @@
             <a:pPr algn="l">
               <a:defRPr sz="1800" b="1">
                 <a:solidFill>
-                  <a:srgbClr val="2563EB"/>
+                  <a:srgbClr val="111827"/>
                 </a:solidFill>
                 <a:latin typeface="Helvetica Neue"/>
                 <a:ea typeface="Helvetica Neue"/>
@@ -2291,7 +2291,7 @@
             <a:r>
               <a:rPr sz="1800" b="1">
                 <a:solidFill>
-                  <a:srgbClr val="2563EB"/>
+                  <a:srgbClr val="111827"/>
                 </a:solidFill>
                 <a:latin typeface="Helvetica Neue"/>
                 <a:ea typeface="Helvetica Neue"/>
@@ -2307,7 +2307,7 @@
           <p:cNvPr id="26" name="">
             <a:extLst xmlns:a="http://schemas.openxmlformats.org/drawingml/2006/main">
               <a:ext uri="{FF2B5EF4-FFF2-40B4-BE49-F238E27FC236}">
-                <a16:creationId xmlns:a16="http://schemas.microsoft.com/office/drawing/2014/main" id="{109C8C29-D011-4E4D-8408-119A7E5EFF14}"/>
+                <a16:creationId xmlns:a16="http://schemas.microsoft.com/office/drawing/2014/main" id="{51D9082D-F82F-4F3C-853F-CEC3705CB0B8}"/>
               </a:ext>
             </a:extLst>
           </p:cNvPr>
@@ -2365,7 +2365,7 @@
           <p:cNvPr id="27" name="">
             <a:extLst xmlns:a="http://schemas.openxmlformats.org/drawingml/2006/main">
               <a:ext uri="{FF2B5EF4-FFF2-40B4-BE49-F238E27FC236}">
-                <a16:creationId xmlns:a16="http://schemas.microsoft.com/office/drawing/2014/main" id="{ED679949-C8B3-4642-9CE2-3EF6CC4E11A8}"/>
+                <a16:creationId xmlns:a16="http://schemas.microsoft.com/office/drawing/2014/main" id="{D1D1F485-1FC1-4947-82CC-77C8035524DE}"/>
               </a:ext>
             </a:extLst>
           </p:cNvPr>
@@ -2383,7 +2383,7 @@
             <a:avLst/>
           </a:prstGeom>
           <a:solidFill xmlns:a="http://schemas.openxmlformats.org/drawingml/2006/main">
-            <a:srgbClr val="EFF6FF"/>
+            <a:srgbClr val="F8FAFC"/>
           </a:solidFill>
           <a:ln xmlns:a="http://schemas.openxmlformats.org/drawingml/2006/main" w="9525">
             <a:solidFill>
@@ -2398,7 +2398,7 @@
           <p:cNvPr id="28" name="">
             <a:extLst xmlns:a="http://schemas.openxmlformats.org/drawingml/2006/main">
               <a:ext uri="{FF2B5EF4-FFF2-40B4-BE49-F238E27FC236}">
-                <a16:creationId xmlns:a16="http://schemas.microsoft.com/office/drawing/2014/main" id="{C64CA3DB-2EEB-4961-A14F-E92689E2D55B}"/>
+                <a16:creationId xmlns:a16="http://schemas.microsoft.com/office/drawing/2014/main" id="{01383292-3E67-4D34-9522-4427287CFB32}"/>
               </a:ext>
             </a:extLst>
           </p:cNvPr>
@@ -2456,7 +2456,7 @@
           <p:cNvPr id="29" name="">
             <a:extLst xmlns:a="http://schemas.openxmlformats.org/drawingml/2006/main">
               <a:ext uri="{FF2B5EF4-FFF2-40B4-BE49-F238E27FC236}">
-                <a16:creationId xmlns:a16="http://schemas.microsoft.com/office/drawing/2014/main" id="{C2BD1043-2CF7-49AC-A124-BFF490DC38E0}"/>
+                <a16:creationId xmlns:a16="http://schemas.microsoft.com/office/drawing/2014/main" id="{D0175A0F-F6BA-4075-AE66-F2CDF84844F2}"/>
               </a:ext>
             </a:extLst>
           </p:cNvPr>
@@ -2488,7 +2488,7 @@
             <a:pPr algn="l">
               <a:defRPr sz="1800" b="1">
                 <a:solidFill>
-                  <a:srgbClr val="2563EB"/>
+                  <a:srgbClr val="111827"/>
                 </a:solidFill>
                 <a:latin typeface="Helvetica Neue"/>
                 <a:ea typeface="Helvetica Neue"/>
@@ -2498,7 +2498,7 @@
             <a:r>
               <a:rPr sz="1800" b="1">
                 <a:solidFill>
-                  <a:srgbClr val="2563EB"/>
+                  <a:srgbClr val="111827"/>
                 </a:solidFill>
                 <a:latin typeface="Helvetica Neue"/>
                 <a:ea typeface="Helvetica Neue"/>
@@ -2514,7 +2514,7 @@
           <p:cNvPr id="30" name="">
             <a:extLst xmlns:a="http://schemas.openxmlformats.org/drawingml/2006/main">
               <a:ext uri="{FF2B5EF4-FFF2-40B4-BE49-F238E27FC236}">
-                <a16:creationId xmlns:a16="http://schemas.microsoft.com/office/drawing/2014/main" id="{24227A4E-7432-44FB-9B3A-1E5D853BA8C6}"/>
+                <a16:creationId xmlns:a16="http://schemas.microsoft.com/office/drawing/2014/main" id="{9E2F5B19-A3ED-44CA-956B-2AA97EA4AA65}"/>
               </a:ext>
             </a:extLst>
           </p:cNvPr>
@@ -2572,7 +2572,7 @@
           <p:cNvPr id="31" name="">
             <a:extLst xmlns:a="http://schemas.openxmlformats.org/drawingml/2006/main">
               <a:ext uri="{FF2B5EF4-FFF2-40B4-BE49-F238E27FC236}">
-                <a16:creationId xmlns:a16="http://schemas.microsoft.com/office/drawing/2014/main" id="{F2BFA820-FB04-4BE1-9753-F682AF21FFB9}"/>
+                <a16:creationId xmlns:a16="http://schemas.microsoft.com/office/drawing/2014/main" id="{BFD72FB1-6DB0-4655-AB40-0808399ED088}"/>
               </a:ext>
             </a:extLst>
           </p:cNvPr>
@@ -2590,7 +2590,7 @@
             <a:avLst/>
           </a:prstGeom>
           <a:solidFill xmlns:a="http://schemas.openxmlformats.org/drawingml/2006/main">
-            <a:srgbClr val="ECFDF5"/>
+            <a:srgbClr val="F8FAFC"/>
           </a:solidFill>
           <a:ln xmlns:a="http://schemas.openxmlformats.org/drawingml/2006/main" w="9525">
             <a:solidFill>
@@ -2605,7 +2605,7 @@
           <p:cNvPr id="32" name="">
             <a:extLst xmlns:a="http://schemas.openxmlformats.org/drawingml/2006/main">
               <a:ext uri="{FF2B5EF4-FFF2-40B4-BE49-F238E27FC236}">
-                <a16:creationId xmlns:a16="http://schemas.microsoft.com/office/drawing/2014/main" id="{D0B9FA64-87A7-4D6C-8F37-A43190BE7C4D}"/>
+                <a16:creationId xmlns:a16="http://schemas.microsoft.com/office/drawing/2014/main" id="{6391C0D2-B9F1-4CE9-84EB-8D8706540760}"/>
               </a:ext>
             </a:extLst>
           </p:cNvPr>
@@ -2663,7 +2663,7 @@
           <p:cNvPr id="33" name="">
             <a:extLst xmlns:a="http://schemas.openxmlformats.org/drawingml/2006/main">
               <a:ext uri="{FF2B5EF4-FFF2-40B4-BE49-F238E27FC236}">
-                <a16:creationId xmlns:a16="http://schemas.microsoft.com/office/drawing/2014/main" id="{8E51946F-805D-4F7F-A427-5968FB974E7D}"/>
+                <a16:creationId xmlns:a16="http://schemas.microsoft.com/office/drawing/2014/main" id="{CABA8637-7237-4EE9-9A00-EA43B8206461}"/>
               </a:ext>
             </a:extLst>
           </p:cNvPr>
@@ -2695,7 +2695,7 @@
             <a:pPr algn="l">
               <a:defRPr sz="1800" b="1">
                 <a:solidFill>
-                  <a:srgbClr val="059669"/>
+                  <a:srgbClr val="111827"/>
                 </a:solidFill>
                 <a:latin typeface="Helvetica Neue"/>
                 <a:ea typeface="Helvetica Neue"/>
@@ -2705,7 +2705,7 @@
             <a:r>
               <a:rPr sz="1800" b="1">
                 <a:solidFill>
-                  <a:srgbClr val="059669"/>
+                  <a:srgbClr val="111827"/>
                 </a:solidFill>
                 <a:latin typeface="Helvetica Neue"/>
                 <a:ea typeface="Helvetica Neue"/>
@@ -2721,7 +2721,7 @@
           <p:cNvPr id="34" name="">
             <a:extLst xmlns:a="http://schemas.openxmlformats.org/drawingml/2006/main">
               <a:ext uri="{FF2B5EF4-FFF2-40B4-BE49-F238E27FC236}">
-                <a16:creationId xmlns:a16="http://schemas.microsoft.com/office/drawing/2014/main" id="{CC598309-D4F1-425D-A749-D44DE4EDD51E}"/>
+                <a16:creationId xmlns:a16="http://schemas.microsoft.com/office/drawing/2014/main" id="{44F301CB-C767-48CC-9C12-C83579389F5F}"/>
               </a:ext>
             </a:extLst>
           </p:cNvPr>
@@ -2779,7 +2779,7 @@
           <p:cNvPr id="35" name="">
             <a:extLst xmlns:a="http://schemas.openxmlformats.org/drawingml/2006/main">
               <a:ext uri="{FF2B5EF4-FFF2-40B4-BE49-F238E27FC236}">
-                <a16:creationId xmlns:a16="http://schemas.microsoft.com/office/drawing/2014/main" id="{E1294595-5950-46AC-A065-27A333EA4249}"/>
+                <a16:creationId xmlns:a16="http://schemas.microsoft.com/office/drawing/2014/main" id="{154322A4-F0DF-4138-A4C5-AF85F9B33287}"/>
               </a:ext>
             </a:extLst>
           </p:cNvPr>
@@ -2797,7 +2797,7 @@
             <a:avLst/>
           </a:prstGeom>
           <a:solidFill xmlns:a="http://schemas.openxmlformats.org/drawingml/2006/main">
-            <a:srgbClr val="ECFDF5"/>
+            <a:srgbClr val="F8FAFC"/>
           </a:solidFill>
           <a:ln xmlns:a="http://schemas.openxmlformats.org/drawingml/2006/main" w="9525">
             <a:solidFill>
@@ -2812,7 +2812,7 @@
           <p:cNvPr id="36" name="">
             <a:extLst xmlns:a="http://schemas.openxmlformats.org/drawingml/2006/main">
               <a:ext uri="{FF2B5EF4-FFF2-40B4-BE49-F238E27FC236}">
-                <a16:creationId xmlns:a16="http://schemas.microsoft.com/office/drawing/2014/main" id="{F348543A-F3A0-4C16-9213-406B50A61447}"/>
+                <a16:creationId xmlns:a16="http://schemas.microsoft.com/office/drawing/2014/main" id="{C5E42FAE-3196-458D-908D-E972F8A72FD5}"/>
               </a:ext>
             </a:extLst>
           </p:cNvPr>
@@ -2870,7 +2870,7 @@
           <p:cNvPr id="37" name="">
             <a:extLst xmlns:a="http://schemas.openxmlformats.org/drawingml/2006/main">
               <a:ext uri="{FF2B5EF4-FFF2-40B4-BE49-F238E27FC236}">
-                <a16:creationId xmlns:a16="http://schemas.microsoft.com/office/drawing/2014/main" id="{8D67B49B-A451-4930-9278-724F9221B5D8}"/>
+                <a16:creationId xmlns:a16="http://schemas.microsoft.com/office/drawing/2014/main" id="{8504B2BE-376A-459B-A3E6-941F7324CE7F}"/>
               </a:ext>
             </a:extLst>
           </p:cNvPr>
@@ -2902,7 +2902,7 @@
             <a:pPr algn="l">
               <a:defRPr sz="1800" b="1">
                 <a:solidFill>
-                  <a:srgbClr val="059669"/>
+                  <a:srgbClr val="111827"/>
                 </a:solidFill>
                 <a:latin typeface="Helvetica Neue"/>
                 <a:ea typeface="Helvetica Neue"/>
@@ -2912,7 +2912,7 @@
             <a:r>
               <a:rPr sz="1800" b="1">
                 <a:solidFill>
-                  <a:srgbClr val="059669"/>
+                  <a:srgbClr val="111827"/>
                 </a:solidFill>
                 <a:latin typeface="Helvetica Neue"/>
                 <a:ea typeface="Helvetica Neue"/>
@@ -2928,7 +2928,7 @@
           <p:cNvPr id="38" name="">
             <a:extLst xmlns:a="http://schemas.openxmlformats.org/drawingml/2006/main">
               <a:ext uri="{FF2B5EF4-FFF2-40B4-BE49-F238E27FC236}">
-                <a16:creationId xmlns:a16="http://schemas.microsoft.com/office/drawing/2014/main" id="{9CC0981F-8A4F-4587-9317-D3B1FA017F44}"/>
+                <a16:creationId xmlns:a16="http://schemas.microsoft.com/office/drawing/2014/main" id="{8C7D942E-9B05-4279-ACF0-490E6BCDE7F3}"/>
               </a:ext>
             </a:extLst>
           </p:cNvPr>
@@ -2986,7 +2986,7 @@
           <p:cNvPr id="39" name="">
             <a:extLst xmlns:a="http://schemas.openxmlformats.org/drawingml/2006/main">
               <a:ext uri="{FF2B5EF4-FFF2-40B4-BE49-F238E27FC236}">
-                <a16:creationId xmlns:a16="http://schemas.microsoft.com/office/drawing/2014/main" id="{D4282293-3A55-412A-B11B-C580824B700A}"/>
+                <a16:creationId xmlns:a16="http://schemas.microsoft.com/office/drawing/2014/main" id="{620D87F7-C77C-4242-9A0D-64FB731A5579}"/>
               </a:ext>
             </a:extLst>
           </p:cNvPr>
@@ -3004,7 +3004,7 @@
             <a:avLst/>
           </a:prstGeom>
           <a:solidFill xmlns:a="http://schemas.openxmlformats.org/drawingml/2006/main">
-            <a:srgbClr val="FFF7ED"/>
+            <a:srgbClr val="F3F6FA"/>
           </a:solidFill>
           <a:ln xmlns:a="http://schemas.openxmlformats.org/drawingml/2006/main" w="9525">
             <a:solidFill>
@@ -3019,7 +3019,7 @@
           <p:cNvPr id="40" name="">
             <a:extLst xmlns:a="http://schemas.openxmlformats.org/drawingml/2006/main">
               <a:ext uri="{FF2B5EF4-FFF2-40B4-BE49-F238E27FC236}">
-                <a16:creationId xmlns:a16="http://schemas.microsoft.com/office/drawing/2014/main" id="{26FB6F19-FAF3-4EC2-B5B9-040A304A2B01}"/>
+                <a16:creationId xmlns:a16="http://schemas.microsoft.com/office/drawing/2014/main" id="{4FA5BF26-4226-44BC-80B8-31166C566D3A}"/>
               </a:ext>
             </a:extLst>
           </p:cNvPr>
@@ -3077,7 +3077,7 @@
           <p:cNvPr id="41" name="">
             <a:extLst xmlns:a="http://schemas.openxmlformats.org/drawingml/2006/main">
               <a:ext uri="{FF2B5EF4-FFF2-40B4-BE49-F238E27FC236}">
-                <a16:creationId xmlns:a16="http://schemas.microsoft.com/office/drawing/2014/main" id="{F8A3D9D1-56FE-4257-9545-B388F7250309}"/>
+                <a16:creationId xmlns:a16="http://schemas.microsoft.com/office/drawing/2014/main" id="{F8116BEC-81A3-4C55-BEE0-77FC951A938C}"/>
               </a:ext>
             </a:extLst>
           </p:cNvPr>
@@ -3109,7 +3109,7 @@
             <a:pPr algn="l">
               <a:defRPr sz="1800" b="1">
                 <a:solidFill>
-                  <a:srgbClr val="B45309"/>
+                  <a:srgbClr val="334155"/>
                 </a:solidFill>
                 <a:latin typeface="Helvetica Neue"/>
                 <a:ea typeface="Helvetica Neue"/>
@@ -3119,7 +3119,7 @@
             <a:r>
               <a:rPr sz="1800" b="1">
                 <a:solidFill>
-                  <a:srgbClr val="B45309"/>
+                  <a:srgbClr val="334155"/>
                 </a:solidFill>
                 <a:latin typeface="Helvetica Neue"/>
                 <a:ea typeface="Helvetica Neue"/>
@@ -3135,7 +3135,7 @@
           <p:cNvPr id="42" name="">
             <a:extLst xmlns:a="http://schemas.openxmlformats.org/drawingml/2006/main">
               <a:ext uri="{FF2B5EF4-FFF2-40B4-BE49-F238E27FC236}">
-                <a16:creationId xmlns:a16="http://schemas.microsoft.com/office/drawing/2014/main" id="{1B805E5A-8E21-4A08-AEB8-DC8993BFD070}"/>
+                <a16:creationId xmlns:a16="http://schemas.microsoft.com/office/drawing/2014/main" id="{CEE43DEF-02ED-4390-A96B-E2F56E2A66CA}"/>
               </a:ext>
             </a:extLst>
           </p:cNvPr>
@@ -3193,7 +3193,7 @@
           <p:cNvPr id="43" name="">
             <a:extLst xmlns:a="http://schemas.openxmlformats.org/drawingml/2006/main">
               <a:ext uri="{FF2B5EF4-FFF2-40B4-BE49-F238E27FC236}">
-                <a16:creationId xmlns:a16="http://schemas.microsoft.com/office/drawing/2014/main" id="{C9C66FCF-96DB-4DF5-B0C7-FF63B21C13B7}"/>
+                <a16:creationId xmlns:a16="http://schemas.microsoft.com/office/drawing/2014/main" id="{408D86BA-A529-42A3-98E1-0A85E5CA6D49}"/>
               </a:ext>
             </a:extLst>
           </p:cNvPr>
@@ -3224,7 +3224,7 @@
           <p:cNvPr id="44" name="">
             <a:extLst xmlns:a="http://schemas.openxmlformats.org/drawingml/2006/main">
               <a:ext uri="{FF2B5EF4-FFF2-40B4-BE49-F238E27FC236}">
-                <a16:creationId xmlns:a16="http://schemas.microsoft.com/office/drawing/2014/main" id="{72B6368F-F21B-4B87-A40C-4492BFB69E03}"/>
+                <a16:creationId xmlns:a16="http://schemas.microsoft.com/office/drawing/2014/main" id="{B0D53049-8224-46DF-8311-DED19D4A0B76}"/>
               </a:ext>
             </a:extLst>
           </p:cNvPr>
@@ -3282,7 +3282,7 @@
           <p:cNvPr id="45" name="">
             <a:extLst xmlns:a="http://schemas.openxmlformats.org/drawingml/2006/main">
               <a:ext uri="{FF2B5EF4-FFF2-40B4-BE49-F238E27FC236}">
-                <a16:creationId xmlns:a16="http://schemas.microsoft.com/office/drawing/2014/main" id="{1FEF3D43-618A-45F5-AC7E-DB560466F0AE}"/>
+                <a16:creationId xmlns:a16="http://schemas.microsoft.com/office/drawing/2014/main" id="{8145F623-17CD-4322-9DFD-32624C3BD5D5}"/>
               </a:ext>
             </a:extLst>
           </p:cNvPr>
@@ -3340,7 +3340,7 @@
           <p:cNvPr id="46" name="">
             <a:extLst xmlns:a="http://schemas.openxmlformats.org/drawingml/2006/main">
               <a:ext uri="{FF2B5EF4-FFF2-40B4-BE49-F238E27FC236}">
-                <a16:creationId xmlns:a16="http://schemas.microsoft.com/office/drawing/2014/main" id="{3CD39EC8-833A-4EE7-BA81-896579D46A45}"/>
+                <a16:creationId xmlns:a16="http://schemas.microsoft.com/office/drawing/2014/main" id="{E00F9897-B246-4FBD-BAB0-7879BC5659D7}"/>
               </a:ext>
             </a:extLst>
           </p:cNvPr>
@@ -3396,7 +3396,7 @@
     </p:spTree>
     <p:extLst>
       <p:ext uri="{BB962C8B-B14F-4D97-AF65-F5344CB8AC3E}">
-        <p14:creationId xmlns:p14="http://schemas.microsoft.com/office/powerpoint/2010/main" val="1808121094"/>
+        <p14:creationId xmlns:p14="http://schemas.microsoft.com/office/powerpoint/2010/main" val="1773079971"/>
       </p:ext>
     </p:extLst>
   </p:cSld>

</xml_diff>

<commit_message>
Clarify scenario 1 replay ordering wording
</commit_message>
<xml_diff>
--- a/presentation/scenario_1_better_deadline_scheduling.pptx
+++ b/presentation/scenario_1_better_deadline_scheduling.pptx
@@ -2,13 +2,13 @@
 <file path=ppt/presentation.xml><?xml version="1.0" encoding="utf-8"?>
 <p:presentation xmlns:p="http://schemas.openxmlformats.org/presentationml/2006/main">
   <p:sldMasterIdLst>
-    <p:sldMasterId xmlns:r="http://schemas.openxmlformats.org/officeDocument/2006/relationships" id="2147483648" r:id="Rba83695a4ee44ac2"/>
+    <p:sldMasterId xmlns:r="http://schemas.openxmlformats.org/officeDocument/2006/relationships" id="2147483648" r:id="R4bf29ad0f58f477d"/>
   </p:sldMasterIdLst>
   <p:notesMasterIdLst>
-    <p:notesMasterId xmlns:r="http://schemas.openxmlformats.org/officeDocument/2006/relationships" r:id="R2527f596c2bc4f93"/>
+    <p:notesMasterId xmlns:r="http://schemas.openxmlformats.org/officeDocument/2006/relationships" r:id="R00d3ced521e0490d"/>
   </p:notesMasterIdLst>
   <p:sldIdLst>
-    <p:sldId xmlns:r="http://schemas.openxmlformats.org/officeDocument/2006/relationships" id="256" r:id="Rc897cdaada4e4ef8"/>
+    <p:sldId xmlns:r="http://schemas.openxmlformats.org/officeDocument/2006/relationships" id="256" r:id="Re3bfed9cfbe44948"/>
   </p:sldIdLst>
   <p:sldSz cx="12192000" cy="6858000"/>
   <p:notesSz cx="6858000" cy="9144000"/>
@@ -452,7 +452,7 @@
           </a:p>
           <a:p xmlns:a="http://schemas.openxmlformats.org/drawingml/2006/main">
             <a:r>
-              <a:t>Setup: same 32 measured replay requests in baseline and controller modes, using the same generated timeline. Baseline uses ordinary FIFO replay submission. Controller mode exposes expected replay timing during tool wait, assigns due-time priority before replay, uses that priority in the local submission gate, and lowers the same priority into SGLang.</a:t>
+              <a:t>Setup: same 32 measured replay requests in baseline and controller modes, using the same generated timeline. Baseline submits replay work in arrival order. Controller mode estimates expected replay timing during tool wait, then releases ready replay requests in deadline order before they enter SGLang. The request payload stays the same; only the release sequence changes.</a:t>
             </a:r>
           </a:p>
           <a:p xmlns:a="http://schemas.openxmlformats.org/drawingml/2006/main">
@@ -555,7 +555,7 @@
   </p:cSld>
   <p:clrMap bg1="lt1" tx1="dk1" bg2="lt2" tx2="dk2" accent1="accent1" accent2="accent2" accent3="accent3" accent4="accent4" accent5="accent5" accent6="accent6" hlink="hlink" folHlink="folHlink"/>
   <p:sldLayoutIdLst>
-    <p:sldLayoutId xmlns:r="http://schemas.openxmlformats.org/officeDocument/2006/relationships" id="2147483649" r:id="R74a13480733a4493"/>
+    <p:sldLayoutId xmlns:r="http://schemas.openxmlformats.org/officeDocument/2006/relationships" id="2147483649" r:id="Ra23d824af6be494b"/>
   </p:sldLayoutIdLst>
   <p:txStyles>
     <p:titleStyle>
@@ -1106,7 +1106,7 @@
           <p:cNvPr id="47" name="">
             <a:extLst xmlns:a="http://schemas.openxmlformats.org/drawingml/2006/main">
               <a:ext uri="{FF2B5EF4-FFF2-40B4-BE49-F238E27FC236}">
-                <a16:creationId xmlns:a16="http://schemas.microsoft.com/office/drawing/2014/main" id="{3BC98D19-F53D-4FF9-8096-28EC7893A51E}"/>
+                <a16:creationId xmlns:a16="http://schemas.microsoft.com/office/drawing/2014/main" id="{BD35262D-0109-43EE-93D5-EB183BBA5B90}"/>
               </a:ext>
             </a:extLst>
           </p:cNvPr>
@@ -1118,7 +1118,7 @@
         <p:spPr>
           <a:xfrm xmlns:a="http://schemas.openxmlformats.org/drawingml/2006/main">
             <a:off x="533400" y="342900"/>
-            <a:ext cx="7429500" cy="457200"/>
+            <a:ext cx="8001000" cy="457200"/>
           </a:xfrm>
           <a:prstGeom xmlns:a="http://schemas.openxmlformats.org/drawingml/2006/main" prst="rect">
             <a:avLst/>
@@ -1154,7 +1154,7 @@
                 <a:ea typeface="Helvetica Neue"/>
                 <a:cs typeface="Helvetica Neue"/>
               </a:rPr>
-              <a:t>Scenario 1: Better Deadline Scheduling</a:t>
+              <a:t>Scenario 1: Deadline-Aware Replay Ordering</a:t>
             </a:r>
           </a:p>
         </p:txBody>
@@ -1164,7 +1164,7 @@
           <p:cNvPr id="2" name="">
             <a:extLst xmlns:a="http://schemas.openxmlformats.org/drawingml/2006/main">
               <a:ext uri="{FF2B5EF4-FFF2-40B4-BE49-F238E27FC236}">
-                <a16:creationId xmlns:a16="http://schemas.microsoft.com/office/drawing/2014/main" id="{33293D1C-A02C-4180-849A-C87FF6775DA8}"/>
+                <a16:creationId xmlns:a16="http://schemas.microsoft.com/office/drawing/2014/main" id="{7359D601-F946-4AD5-915A-06791C15A862}"/>
               </a:ext>
             </a:extLst>
           </p:cNvPr>
@@ -1212,7 +1212,7 @@
                 <a:ea typeface="Helvetica Neue"/>
                 <a:cs typeface="Helvetica Neue"/>
               </a:rPr>
-              <a:t>Harness timing signals help the backend serve soon-due replay work first.</a:t>
+              <a:t>Harness timing estimates when agents resume, then releases replay work in deadline order.</a:t>
             </a:r>
           </a:p>
         </p:txBody>
@@ -1222,7 +1222,7 @@
           <p:cNvPr id="3" name="">
             <a:extLst xmlns:a="http://schemas.openxmlformats.org/drawingml/2006/main">
               <a:ext uri="{FF2B5EF4-FFF2-40B4-BE49-F238E27FC236}">
-                <a16:creationId xmlns:a16="http://schemas.microsoft.com/office/drawing/2014/main" id="{980AE924-EF0E-4825-B250-42B88BA3B71E}"/>
+                <a16:creationId xmlns:a16="http://schemas.microsoft.com/office/drawing/2014/main" id="{90765368-5ED0-42C2-B101-BA8782D61C87}"/>
               </a:ext>
             </a:extLst>
           </p:cNvPr>
@@ -1280,7 +1280,7 @@
           <p:cNvPr id="4" name="">
             <a:extLst xmlns:a="http://schemas.openxmlformats.org/drawingml/2006/main">
               <a:ext uri="{FF2B5EF4-FFF2-40B4-BE49-F238E27FC236}">
-                <a16:creationId xmlns:a16="http://schemas.microsoft.com/office/drawing/2014/main" id="{6EE27B54-0CD6-4221-AEA6-F93AF7F754F5}"/>
+                <a16:creationId xmlns:a16="http://schemas.microsoft.com/office/drawing/2014/main" id="{6BC50C45-E50E-4B3C-BED3-7E9B255625CD}"/>
               </a:ext>
             </a:extLst>
           </p:cNvPr>
@@ -1311,7 +1311,7 @@
           <p:cNvPr id="5" name="">
             <a:extLst xmlns:a="http://schemas.openxmlformats.org/drawingml/2006/main">
               <a:ext uri="{FF2B5EF4-FFF2-40B4-BE49-F238E27FC236}">
-                <a16:creationId xmlns:a16="http://schemas.microsoft.com/office/drawing/2014/main" id="{E187358B-7E66-46E7-A5E4-D8E5FFDD341D}"/>
+                <a16:creationId xmlns:a16="http://schemas.microsoft.com/office/drawing/2014/main" id="{910857D4-9750-49D4-915D-339E95792084}"/>
               </a:ext>
             </a:extLst>
           </p:cNvPr>
@@ -1369,7 +1369,7 @@
           <p:cNvPr id="6" name="">
             <a:extLst xmlns:a="http://schemas.openxmlformats.org/drawingml/2006/main">
               <a:ext uri="{FF2B5EF4-FFF2-40B4-BE49-F238E27FC236}">
-                <a16:creationId xmlns:a16="http://schemas.microsoft.com/office/drawing/2014/main" id="{D14FAC1A-EF9B-4F59-8D42-730AA1EC08FE}"/>
+                <a16:creationId xmlns:a16="http://schemas.microsoft.com/office/drawing/2014/main" id="{D4EE0477-8DFB-4B0B-A7A5-58249646EC56}"/>
               </a:ext>
             </a:extLst>
           </p:cNvPr>
@@ -1409,7 +1409,7 @@
           <p:cNvPr id="7" name="">
             <a:extLst xmlns:a="http://schemas.openxmlformats.org/drawingml/2006/main">
               <a:ext uri="{FF2B5EF4-FFF2-40B4-BE49-F238E27FC236}">
-                <a16:creationId xmlns:a16="http://schemas.microsoft.com/office/drawing/2014/main" id="{F5C50361-84EE-4FA5-85FE-BA0C0169C46D}"/>
+                <a16:creationId xmlns:a16="http://schemas.microsoft.com/office/drawing/2014/main" id="{EE12236E-3E78-4246-BF91-4716F8DB5D23}"/>
               </a:ext>
             </a:extLst>
           </p:cNvPr>
@@ -1442,7 +1442,7 @@
           <p:cNvPr id="8" name="">
             <a:extLst xmlns:a="http://schemas.openxmlformats.org/drawingml/2006/main">
               <a:ext uri="{FF2B5EF4-FFF2-40B4-BE49-F238E27FC236}">
-                <a16:creationId xmlns:a16="http://schemas.microsoft.com/office/drawing/2014/main" id="{381C076F-DAF8-4A9C-9C5A-7CB75FDD53F1}"/>
+                <a16:creationId xmlns:a16="http://schemas.microsoft.com/office/drawing/2014/main" id="{AB9E4BF6-D1C6-4615-A682-EFFD4C63D7AB}"/>
               </a:ext>
             </a:extLst>
           </p:cNvPr>
@@ -1500,7 +1500,7 @@
           <p:cNvPr id="9" name="">
             <a:extLst xmlns:a="http://schemas.openxmlformats.org/drawingml/2006/main">
               <a:ext uri="{FF2B5EF4-FFF2-40B4-BE49-F238E27FC236}">
-                <a16:creationId xmlns:a16="http://schemas.microsoft.com/office/drawing/2014/main" id="{D2E079A9-983B-431C-8AA8-972C8F3A0620}"/>
+                <a16:creationId xmlns:a16="http://schemas.microsoft.com/office/drawing/2014/main" id="{EBDC7703-DDB5-49EE-A586-0750D9B77D1A}"/>
               </a:ext>
             </a:extLst>
           </p:cNvPr>
@@ -1540,7 +1540,7 @@
           <p:cNvPr id="10" name="">
             <a:extLst xmlns:a="http://schemas.openxmlformats.org/drawingml/2006/main">
               <a:ext uri="{FF2B5EF4-FFF2-40B4-BE49-F238E27FC236}">
-                <a16:creationId xmlns:a16="http://schemas.microsoft.com/office/drawing/2014/main" id="{2B84841C-6321-486A-9B29-908128B7D7C9}"/>
+                <a16:creationId xmlns:a16="http://schemas.microsoft.com/office/drawing/2014/main" id="{AE4A05F3-6E4A-49FD-869B-6687BBDA9FFB}"/>
               </a:ext>
             </a:extLst>
           </p:cNvPr>
@@ -1573,7 +1573,7 @@
           <p:cNvPr id="11" name="">
             <a:extLst xmlns:a="http://schemas.openxmlformats.org/drawingml/2006/main">
               <a:ext uri="{FF2B5EF4-FFF2-40B4-BE49-F238E27FC236}">
-                <a16:creationId xmlns:a16="http://schemas.microsoft.com/office/drawing/2014/main" id="{457F0449-4B20-4DB3-8185-52D336ACCBFD}"/>
+                <a16:creationId xmlns:a16="http://schemas.microsoft.com/office/drawing/2014/main" id="{81F790DC-384D-4191-935B-616C9C2B5ED8}"/>
               </a:ext>
             </a:extLst>
           </p:cNvPr>
@@ -1631,7 +1631,7 @@
           <p:cNvPr id="12" name="">
             <a:extLst xmlns:a="http://schemas.openxmlformats.org/drawingml/2006/main">
               <a:ext uri="{FF2B5EF4-FFF2-40B4-BE49-F238E27FC236}">
-                <a16:creationId xmlns:a16="http://schemas.microsoft.com/office/drawing/2014/main" id="{1A7DF230-69C3-42C5-9FDD-FAA032E3CE07}"/>
+                <a16:creationId xmlns:a16="http://schemas.microsoft.com/office/drawing/2014/main" id="{F02F1FA7-E25E-410A-8BAE-50E03D9B7226}"/>
               </a:ext>
             </a:extLst>
           </p:cNvPr>
@@ -1671,7 +1671,7 @@
           <p:cNvPr id="13" name="">
             <a:extLst xmlns:a="http://schemas.openxmlformats.org/drawingml/2006/main">
               <a:ext uri="{FF2B5EF4-FFF2-40B4-BE49-F238E27FC236}">
-                <a16:creationId xmlns:a16="http://schemas.microsoft.com/office/drawing/2014/main" id="{F5B54E69-5EF6-4DB7-8445-6D7068F69663}"/>
+                <a16:creationId xmlns:a16="http://schemas.microsoft.com/office/drawing/2014/main" id="{6F0F6663-5172-4C52-950F-430FDA563B61}"/>
               </a:ext>
             </a:extLst>
           </p:cNvPr>
@@ -1704,7 +1704,7 @@
           <p:cNvPr id="14" name="">
             <a:extLst xmlns:a="http://schemas.openxmlformats.org/drawingml/2006/main">
               <a:ext uri="{FF2B5EF4-FFF2-40B4-BE49-F238E27FC236}">
-                <a16:creationId xmlns:a16="http://schemas.microsoft.com/office/drawing/2014/main" id="{128DD02C-4570-4E10-A5EB-EA8F37710D42}"/>
+                <a16:creationId xmlns:a16="http://schemas.microsoft.com/office/drawing/2014/main" id="{05D2804A-B3FF-4B56-9149-6652F4FCC5DC}"/>
               </a:ext>
             </a:extLst>
           </p:cNvPr>
@@ -1762,7 +1762,7 @@
           <p:cNvPr id="15" name="">
             <a:extLst xmlns:a="http://schemas.openxmlformats.org/drawingml/2006/main">
               <a:ext uri="{FF2B5EF4-FFF2-40B4-BE49-F238E27FC236}">
-                <a16:creationId xmlns:a16="http://schemas.microsoft.com/office/drawing/2014/main" id="{E0F085D4-A666-41AD-B45A-5254E67D3DB7}"/>
+                <a16:creationId xmlns:a16="http://schemas.microsoft.com/office/drawing/2014/main" id="{ABE28B2F-6F82-499F-8D86-299B4F6E7844}"/>
               </a:ext>
             </a:extLst>
           </p:cNvPr>
@@ -1802,7 +1802,7 @@
           <p:cNvPr id="16" name="">
             <a:extLst xmlns:a="http://schemas.openxmlformats.org/drawingml/2006/main">
               <a:ext uri="{FF2B5EF4-FFF2-40B4-BE49-F238E27FC236}">
-                <a16:creationId xmlns:a16="http://schemas.microsoft.com/office/drawing/2014/main" id="{BE3C5693-D32A-4ACD-9BF7-DB82563C3C4D}"/>
+                <a16:creationId xmlns:a16="http://schemas.microsoft.com/office/drawing/2014/main" id="{CD1639B2-CF42-4910-8635-37ACF7EADED2}"/>
               </a:ext>
             </a:extLst>
           </p:cNvPr>
@@ -1835,7 +1835,7 @@
           <p:cNvPr id="17" name="">
             <a:extLst xmlns:a="http://schemas.openxmlformats.org/drawingml/2006/main">
               <a:ext uri="{FF2B5EF4-FFF2-40B4-BE49-F238E27FC236}">
-                <a16:creationId xmlns:a16="http://schemas.microsoft.com/office/drawing/2014/main" id="{BEA6E994-A423-4BDA-B1C5-CCC50232FEE5}"/>
+                <a16:creationId xmlns:a16="http://schemas.microsoft.com/office/drawing/2014/main" id="{C91A8B99-5357-4A5C-905B-9D8C65406F65}"/>
               </a:ext>
             </a:extLst>
           </p:cNvPr>
@@ -1883,7 +1883,7 @@
                 <a:ea typeface="Helvetica Neue"/>
                 <a:cs typeface="Helvetica Neue"/>
               </a:rPr>
-              <a:t>Baseline uses FIFO replay submission.</a:t>
+              <a:t>Baseline submits replay work in arrival order.</a:t>
             </a:r>
           </a:p>
         </p:txBody>
@@ -1893,7 +1893,7 @@
           <p:cNvPr id="18" name="">
             <a:extLst xmlns:a="http://schemas.openxmlformats.org/drawingml/2006/main">
               <a:ext uri="{FF2B5EF4-FFF2-40B4-BE49-F238E27FC236}">
-                <a16:creationId xmlns:a16="http://schemas.microsoft.com/office/drawing/2014/main" id="{AC501E61-E296-4F95-AB2D-2A2DA9B89E72}"/>
+                <a16:creationId xmlns:a16="http://schemas.microsoft.com/office/drawing/2014/main" id="{702C9F69-71FF-46D7-A73A-E96DB8D8676F}"/>
               </a:ext>
             </a:extLst>
           </p:cNvPr>
@@ -1926,7 +1926,7 @@
           <p:cNvPr id="19" name="">
             <a:extLst xmlns:a="http://schemas.openxmlformats.org/drawingml/2006/main">
               <a:ext uri="{FF2B5EF4-FFF2-40B4-BE49-F238E27FC236}">
-                <a16:creationId xmlns:a16="http://schemas.microsoft.com/office/drawing/2014/main" id="{07C2014C-FB4A-4FFA-B725-45B83FDFD37F}"/>
+                <a16:creationId xmlns:a16="http://schemas.microsoft.com/office/drawing/2014/main" id="{41F4A8B2-76DF-42FE-AA61-B447560DF2F7}"/>
               </a:ext>
             </a:extLst>
           </p:cNvPr>
@@ -1984,7 +1984,7 @@
           <p:cNvPr id="20" name="">
             <a:extLst xmlns:a="http://schemas.openxmlformats.org/drawingml/2006/main">
               <a:ext uri="{FF2B5EF4-FFF2-40B4-BE49-F238E27FC236}">
-                <a16:creationId xmlns:a16="http://schemas.microsoft.com/office/drawing/2014/main" id="{BBF48F68-6559-4E96-8E5C-5C3C7F28CF17}"/>
+                <a16:creationId xmlns:a16="http://schemas.microsoft.com/office/drawing/2014/main" id="{B0E8755A-4585-4D49-A789-583E5F28E4E8}"/>
               </a:ext>
             </a:extLst>
           </p:cNvPr>
@@ -2032,7 +2032,7 @@
                 <a:ea typeface="Helvetica Neue"/>
                 <a:cs typeface="Helvetica Neue"/>
               </a:rPr>
-              <a:t>It gives the soonest-due replay the highest priority, applies that order before SGLang through the local submission gate, then passes the same priority into SGLang scheduling.</a:t>
+              <a:t>It estimates when each agent will resume, then releases ready replay requests in deadline order. The request payload stays the same; only the release sequence changes.</a:t>
             </a:r>
           </a:p>
         </p:txBody>
@@ -2042,7 +2042,7 @@
           <p:cNvPr id="21" name="">
             <a:extLst xmlns:a="http://schemas.openxmlformats.org/drawingml/2006/main">
               <a:ext uri="{FF2B5EF4-FFF2-40B4-BE49-F238E27FC236}">
-                <a16:creationId xmlns:a16="http://schemas.microsoft.com/office/drawing/2014/main" id="{E8B29F46-BC99-4D2D-BED5-4A58A5BDE7FC}"/>
+                <a16:creationId xmlns:a16="http://schemas.microsoft.com/office/drawing/2014/main" id="{56933F51-4B2A-4616-9EA3-96E811FC3390}"/>
               </a:ext>
             </a:extLst>
           </p:cNvPr>
@@ -2100,7 +2100,7 @@
           <p:cNvPr id="22" name="">
             <a:extLst xmlns:a="http://schemas.openxmlformats.org/drawingml/2006/main">
               <a:ext uri="{FF2B5EF4-FFF2-40B4-BE49-F238E27FC236}">
-                <a16:creationId xmlns:a16="http://schemas.microsoft.com/office/drawing/2014/main" id="{35110F0B-39E0-4FFA-8258-C7A161D8ECAC}"/>
+                <a16:creationId xmlns:a16="http://schemas.microsoft.com/office/drawing/2014/main" id="{E420053D-4410-46A2-A73D-E3A13E4E59D1}"/>
               </a:ext>
             </a:extLst>
           </p:cNvPr>
@@ -2158,7 +2158,7 @@
           <p:cNvPr id="23" name="">
             <a:extLst xmlns:a="http://schemas.openxmlformats.org/drawingml/2006/main">
               <a:ext uri="{FF2B5EF4-FFF2-40B4-BE49-F238E27FC236}">
-                <a16:creationId xmlns:a16="http://schemas.microsoft.com/office/drawing/2014/main" id="{DA1D0572-D019-45CF-9A30-A8B843AEEB82}"/>
+                <a16:creationId xmlns:a16="http://schemas.microsoft.com/office/drawing/2014/main" id="{1B687D57-3DAC-4366-B372-3121802814FC}"/>
               </a:ext>
             </a:extLst>
           </p:cNvPr>
@@ -2191,7 +2191,7 @@
           <p:cNvPr id="24" name="">
             <a:extLst xmlns:a="http://schemas.openxmlformats.org/drawingml/2006/main">
               <a:ext uri="{FF2B5EF4-FFF2-40B4-BE49-F238E27FC236}">
-                <a16:creationId xmlns:a16="http://schemas.microsoft.com/office/drawing/2014/main" id="{8E4FA3B9-B6C6-4DCB-97EF-4F92787A021C}"/>
+                <a16:creationId xmlns:a16="http://schemas.microsoft.com/office/drawing/2014/main" id="{E0EE0FB5-F9B9-4751-BDCC-5FBDAC08D75B}"/>
               </a:ext>
             </a:extLst>
           </p:cNvPr>
@@ -2249,7 +2249,7 @@
           <p:cNvPr id="25" name="">
             <a:extLst xmlns:a="http://schemas.openxmlformats.org/drawingml/2006/main">
               <a:ext uri="{FF2B5EF4-FFF2-40B4-BE49-F238E27FC236}">
-                <a16:creationId xmlns:a16="http://schemas.microsoft.com/office/drawing/2014/main" id="{B69AD552-F8DE-49EF-BF48-C117DBD75C1C}"/>
+                <a16:creationId xmlns:a16="http://schemas.microsoft.com/office/drawing/2014/main" id="{D15853E6-CE1E-470C-88CC-EDB19D31990E}"/>
               </a:ext>
             </a:extLst>
           </p:cNvPr>
@@ -2307,7 +2307,7 @@
           <p:cNvPr id="26" name="">
             <a:extLst xmlns:a="http://schemas.openxmlformats.org/drawingml/2006/main">
               <a:ext uri="{FF2B5EF4-FFF2-40B4-BE49-F238E27FC236}">
-                <a16:creationId xmlns:a16="http://schemas.microsoft.com/office/drawing/2014/main" id="{51D9082D-F82F-4F3C-853F-CEC3705CB0B8}"/>
+                <a16:creationId xmlns:a16="http://schemas.microsoft.com/office/drawing/2014/main" id="{51A09438-1216-47DA-AA7F-FA7DA4A37846}"/>
               </a:ext>
             </a:extLst>
           </p:cNvPr>
@@ -2365,7 +2365,7 @@
           <p:cNvPr id="27" name="">
             <a:extLst xmlns:a="http://schemas.openxmlformats.org/drawingml/2006/main">
               <a:ext uri="{FF2B5EF4-FFF2-40B4-BE49-F238E27FC236}">
-                <a16:creationId xmlns:a16="http://schemas.microsoft.com/office/drawing/2014/main" id="{D1D1F485-1FC1-4947-82CC-77C8035524DE}"/>
+                <a16:creationId xmlns:a16="http://schemas.microsoft.com/office/drawing/2014/main" id="{A45BE445-14CC-4060-9154-807CDB2356B3}"/>
               </a:ext>
             </a:extLst>
           </p:cNvPr>
@@ -2398,7 +2398,7 @@
           <p:cNvPr id="28" name="">
             <a:extLst xmlns:a="http://schemas.openxmlformats.org/drawingml/2006/main">
               <a:ext uri="{FF2B5EF4-FFF2-40B4-BE49-F238E27FC236}">
-                <a16:creationId xmlns:a16="http://schemas.microsoft.com/office/drawing/2014/main" id="{01383292-3E67-4D34-9522-4427287CFB32}"/>
+                <a16:creationId xmlns:a16="http://schemas.microsoft.com/office/drawing/2014/main" id="{CA6AFC8D-91B2-4615-97CD-49E3DD617446}"/>
               </a:ext>
             </a:extLst>
           </p:cNvPr>
@@ -2456,7 +2456,7 @@
           <p:cNvPr id="29" name="">
             <a:extLst xmlns:a="http://schemas.openxmlformats.org/drawingml/2006/main">
               <a:ext uri="{FF2B5EF4-FFF2-40B4-BE49-F238E27FC236}">
-                <a16:creationId xmlns:a16="http://schemas.microsoft.com/office/drawing/2014/main" id="{D0175A0F-F6BA-4075-AE66-F2CDF84844F2}"/>
+                <a16:creationId xmlns:a16="http://schemas.microsoft.com/office/drawing/2014/main" id="{6003DF71-A8C7-4A00-A696-42899AF490A2}"/>
               </a:ext>
             </a:extLst>
           </p:cNvPr>
@@ -2514,7 +2514,7 @@
           <p:cNvPr id="30" name="">
             <a:extLst xmlns:a="http://schemas.openxmlformats.org/drawingml/2006/main">
               <a:ext uri="{FF2B5EF4-FFF2-40B4-BE49-F238E27FC236}">
-                <a16:creationId xmlns:a16="http://schemas.microsoft.com/office/drawing/2014/main" id="{9E2F5B19-A3ED-44CA-956B-2AA97EA4AA65}"/>
+                <a16:creationId xmlns:a16="http://schemas.microsoft.com/office/drawing/2014/main" id="{922E42E6-A836-41A9-A4C9-2A74F667A2C6}"/>
               </a:ext>
             </a:extLst>
           </p:cNvPr>
@@ -2572,7 +2572,7 @@
           <p:cNvPr id="31" name="">
             <a:extLst xmlns:a="http://schemas.openxmlformats.org/drawingml/2006/main">
               <a:ext uri="{FF2B5EF4-FFF2-40B4-BE49-F238E27FC236}">
-                <a16:creationId xmlns:a16="http://schemas.microsoft.com/office/drawing/2014/main" id="{BFD72FB1-6DB0-4655-AB40-0808399ED088}"/>
+                <a16:creationId xmlns:a16="http://schemas.microsoft.com/office/drawing/2014/main" id="{AB330CDC-617F-4249-BBAB-CFF83CEB5FD3}"/>
               </a:ext>
             </a:extLst>
           </p:cNvPr>
@@ -2605,7 +2605,7 @@
           <p:cNvPr id="32" name="">
             <a:extLst xmlns:a="http://schemas.openxmlformats.org/drawingml/2006/main">
               <a:ext uri="{FF2B5EF4-FFF2-40B4-BE49-F238E27FC236}">
-                <a16:creationId xmlns:a16="http://schemas.microsoft.com/office/drawing/2014/main" id="{6391C0D2-B9F1-4CE9-84EB-8D8706540760}"/>
+                <a16:creationId xmlns:a16="http://schemas.microsoft.com/office/drawing/2014/main" id="{C9572E2A-7C45-4E5A-910B-14419BEE3CBA}"/>
               </a:ext>
             </a:extLst>
           </p:cNvPr>
@@ -2663,7 +2663,7 @@
           <p:cNvPr id="33" name="">
             <a:extLst xmlns:a="http://schemas.openxmlformats.org/drawingml/2006/main">
               <a:ext uri="{FF2B5EF4-FFF2-40B4-BE49-F238E27FC236}">
-                <a16:creationId xmlns:a16="http://schemas.microsoft.com/office/drawing/2014/main" id="{CABA8637-7237-4EE9-9A00-EA43B8206461}"/>
+                <a16:creationId xmlns:a16="http://schemas.microsoft.com/office/drawing/2014/main" id="{FAEA3593-A2F2-4A3B-B16B-DE6636233443}"/>
               </a:ext>
             </a:extLst>
           </p:cNvPr>
@@ -2721,7 +2721,7 @@
           <p:cNvPr id="34" name="">
             <a:extLst xmlns:a="http://schemas.openxmlformats.org/drawingml/2006/main">
               <a:ext uri="{FF2B5EF4-FFF2-40B4-BE49-F238E27FC236}">
-                <a16:creationId xmlns:a16="http://schemas.microsoft.com/office/drawing/2014/main" id="{44F301CB-C767-48CC-9C12-C83579389F5F}"/>
+                <a16:creationId xmlns:a16="http://schemas.microsoft.com/office/drawing/2014/main" id="{87815105-8FAB-48D0-B77A-C2C812C0714B}"/>
               </a:ext>
             </a:extLst>
           </p:cNvPr>
@@ -2779,7 +2779,7 @@
           <p:cNvPr id="35" name="">
             <a:extLst xmlns:a="http://schemas.openxmlformats.org/drawingml/2006/main">
               <a:ext uri="{FF2B5EF4-FFF2-40B4-BE49-F238E27FC236}">
-                <a16:creationId xmlns:a16="http://schemas.microsoft.com/office/drawing/2014/main" id="{154322A4-F0DF-4138-A4C5-AF85F9B33287}"/>
+                <a16:creationId xmlns:a16="http://schemas.microsoft.com/office/drawing/2014/main" id="{3A6B3F75-CD2C-4413-908C-17CA003DDBAA}"/>
               </a:ext>
             </a:extLst>
           </p:cNvPr>
@@ -2812,7 +2812,7 @@
           <p:cNvPr id="36" name="">
             <a:extLst xmlns:a="http://schemas.openxmlformats.org/drawingml/2006/main">
               <a:ext uri="{FF2B5EF4-FFF2-40B4-BE49-F238E27FC236}">
-                <a16:creationId xmlns:a16="http://schemas.microsoft.com/office/drawing/2014/main" id="{C5E42FAE-3196-458D-908D-E972F8A72FD5}"/>
+                <a16:creationId xmlns:a16="http://schemas.microsoft.com/office/drawing/2014/main" id="{CC974B42-47D0-4671-86FB-8FF2885A34DD}"/>
               </a:ext>
             </a:extLst>
           </p:cNvPr>
@@ -2870,7 +2870,7 @@
           <p:cNvPr id="37" name="">
             <a:extLst xmlns:a="http://schemas.openxmlformats.org/drawingml/2006/main">
               <a:ext uri="{FF2B5EF4-FFF2-40B4-BE49-F238E27FC236}">
-                <a16:creationId xmlns:a16="http://schemas.microsoft.com/office/drawing/2014/main" id="{8504B2BE-376A-459B-A3E6-941F7324CE7F}"/>
+                <a16:creationId xmlns:a16="http://schemas.microsoft.com/office/drawing/2014/main" id="{6E9453F7-B51E-4D81-9AA4-F49678703AE0}"/>
               </a:ext>
             </a:extLst>
           </p:cNvPr>
@@ -2928,7 +2928,7 @@
           <p:cNvPr id="38" name="">
             <a:extLst xmlns:a="http://schemas.openxmlformats.org/drawingml/2006/main">
               <a:ext uri="{FF2B5EF4-FFF2-40B4-BE49-F238E27FC236}">
-                <a16:creationId xmlns:a16="http://schemas.microsoft.com/office/drawing/2014/main" id="{8C7D942E-9B05-4279-ACF0-490E6BCDE7F3}"/>
+                <a16:creationId xmlns:a16="http://schemas.microsoft.com/office/drawing/2014/main" id="{C9163635-600F-46C2-8AC9-CDC97949E195}"/>
               </a:ext>
             </a:extLst>
           </p:cNvPr>
@@ -2986,7 +2986,7 @@
           <p:cNvPr id="39" name="">
             <a:extLst xmlns:a="http://schemas.openxmlformats.org/drawingml/2006/main">
               <a:ext uri="{FF2B5EF4-FFF2-40B4-BE49-F238E27FC236}">
-                <a16:creationId xmlns:a16="http://schemas.microsoft.com/office/drawing/2014/main" id="{620D87F7-C77C-4242-9A0D-64FB731A5579}"/>
+                <a16:creationId xmlns:a16="http://schemas.microsoft.com/office/drawing/2014/main" id="{015FF66D-0A89-4359-ACBD-916CCFD2938B}"/>
               </a:ext>
             </a:extLst>
           </p:cNvPr>
@@ -3019,7 +3019,7 @@
           <p:cNvPr id="40" name="">
             <a:extLst xmlns:a="http://schemas.openxmlformats.org/drawingml/2006/main">
               <a:ext uri="{FF2B5EF4-FFF2-40B4-BE49-F238E27FC236}">
-                <a16:creationId xmlns:a16="http://schemas.microsoft.com/office/drawing/2014/main" id="{4FA5BF26-4226-44BC-80B8-31166C566D3A}"/>
+                <a16:creationId xmlns:a16="http://schemas.microsoft.com/office/drawing/2014/main" id="{B41E615A-E5F7-43C1-8677-13EA909F70CC}"/>
               </a:ext>
             </a:extLst>
           </p:cNvPr>
@@ -3077,7 +3077,7 @@
           <p:cNvPr id="41" name="">
             <a:extLst xmlns:a="http://schemas.openxmlformats.org/drawingml/2006/main">
               <a:ext uri="{FF2B5EF4-FFF2-40B4-BE49-F238E27FC236}">
-                <a16:creationId xmlns:a16="http://schemas.microsoft.com/office/drawing/2014/main" id="{F8116BEC-81A3-4C55-BEE0-77FC951A938C}"/>
+                <a16:creationId xmlns:a16="http://schemas.microsoft.com/office/drawing/2014/main" id="{95C26118-7F77-4B8A-B370-81B4F59DADBB}"/>
               </a:ext>
             </a:extLst>
           </p:cNvPr>
@@ -3135,7 +3135,7 @@
           <p:cNvPr id="42" name="">
             <a:extLst xmlns:a="http://schemas.openxmlformats.org/drawingml/2006/main">
               <a:ext uri="{FF2B5EF4-FFF2-40B4-BE49-F238E27FC236}">
-                <a16:creationId xmlns:a16="http://schemas.microsoft.com/office/drawing/2014/main" id="{CEE43DEF-02ED-4390-A96B-E2F56E2A66CA}"/>
+                <a16:creationId xmlns:a16="http://schemas.microsoft.com/office/drawing/2014/main" id="{C287A86F-D68C-45D1-B398-EA19FE3F9A49}"/>
               </a:ext>
             </a:extLst>
           </p:cNvPr>
@@ -3193,7 +3193,7 @@
           <p:cNvPr id="43" name="">
             <a:extLst xmlns:a="http://schemas.openxmlformats.org/drawingml/2006/main">
               <a:ext uri="{FF2B5EF4-FFF2-40B4-BE49-F238E27FC236}">
-                <a16:creationId xmlns:a16="http://schemas.microsoft.com/office/drawing/2014/main" id="{408D86BA-A529-42A3-98E1-0A85E5CA6D49}"/>
+                <a16:creationId xmlns:a16="http://schemas.microsoft.com/office/drawing/2014/main" id="{2B82EF0F-86E6-4AC9-B7E6-D6F9E519B322}"/>
               </a:ext>
             </a:extLst>
           </p:cNvPr>
@@ -3224,7 +3224,7 @@
           <p:cNvPr id="44" name="">
             <a:extLst xmlns:a="http://schemas.openxmlformats.org/drawingml/2006/main">
               <a:ext uri="{FF2B5EF4-FFF2-40B4-BE49-F238E27FC236}">
-                <a16:creationId xmlns:a16="http://schemas.microsoft.com/office/drawing/2014/main" id="{B0D53049-8224-46DF-8311-DED19D4A0B76}"/>
+                <a16:creationId xmlns:a16="http://schemas.microsoft.com/office/drawing/2014/main" id="{C151799A-C233-4227-B7B0-91FB11E12291}"/>
               </a:ext>
             </a:extLst>
           </p:cNvPr>
@@ -3282,7 +3282,7 @@
           <p:cNvPr id="45" name="">
             <a:extLst xmlns:a="http://schemas.openxmlformats.org/drawingml/2006/main">
               <a:ext uri="{FF2B5EF4-FFF2-40B4-BE49-F238E27FC236}">
-                <a16:creationId xmlns:a16="http://schemas.microsoft.com/office/drawing/2014/main" id="{8145F623-17CD-4322-9DFD-32624C3BD5D5}"/>
+                <a16:creationId xmlns:a16="http://schemas.microsoft.com/office/drawing/2014/main" id="{06F39AA0-D8D0-4CD2-A46F-3F84B5860A40}"/>
               </a:ext>
             </a:extLst>
           </p:cNvPr>
@@ -3330,7 +3330,7 @@
                 <a:ea typeface="Helvetica Neue"/>
                 <a:cs typeface="Helvetica Neue"/>
               </a:rPr>
-              <a:t>Harness-aware scheduling reduced replay delay across the full workload, not just one target request.</a:t>
+              <a:t>Using harness timing to order replay work reduced replay delay across the full workload.</a:t>
             </a:r>
           </a:p>
         </p:txBody>
@@ -3340,7 +3340,7 @@
           <p:cNvPr id="46" name="">
             <a:extLst xmlns:a="http://schemas.openxmlformats.org/drawingml/2006/main">
               <a:ext uri="{FF2B5EF4-FFF2-40B4-BE49-F238E27FC236}">
-                <a16:creationId xmlns:a16="http://schemas.microsoft.com/office/drawing/2014/main" id="{E00F9897-B246-4FBD-BAB0-7879BC5659D7}"/>
+                <a16:creationId xmlns:a16="http://schemas.microsoft.com/office/drawing/2014/main" id="{CB382AA1-35C8-4584-A8B3-F6B9687B4C77}"/>
               </a:ext>
             </a:extLst>
           </p:cNvPr>
@@ -3396,7 +3396,7 @@
     </p:spTree>
     <p:extLst>
       <p:ext uri="{BB962C8B-B14F-4D97-AF65-F5344CB8AC3E}">
-        <p14:creationId xmlns:p14="http://schemas.microsoft.com/office/powerpoint/2010/main" val="1773079971"/>
+        <p14:creationId xmlns:p14="http://schemas.microsoft.com/office/powerpoint/2010/main" val="1323881208"/>
       </p:ext>
     </p:extLst>
   </p:cSld>

</xml_diff>